<commit_message>
Edited the presentation a bit so that the water is just above the watershed
</commit_message>
<xml_diff>
--- a/Comp_Vis_slides.pptx
+++ b/Comp_Vis_slides.pptx
@@ -1786,7 +1786,7 @@
           <a:p>
             <a:fld id="{5BCAD085-E8A6-8845-BD4E-CB4CCA059FC4}" type="datetimeFigureOut">
               <a:rPr lang="en-US" smtClean="0"/>
-              <a:t>5/15/26</a:t>
+              <a:t>5/18/26</a:t>
             </a:fld>
             <a:endParaRPr lang="en-US"/>
           </a:p>
@@ -1954,7 +1954,7 @@
           <a:p>
             <a:fld id="{5BCAD085-E8A6-8845-BD4E-CB4CCA059FC4}" type="datetimeFigureOut">
               <a:rPr lang="en-US" smtClean="0"/>
-              <a:t>5/15/26</a:t>
+              <a:t>5/18/26</a:t>
             </a:fld>
             <a:endParaRPr lang="en-US"/>
           </a:p>
@@ -2132,7 +2132,7 @@
           <a:p>
             <a:fld id="{5BCAD085-E8A6-8845-BD4E-CB4CCA059FC4}" type="datetimeFigureOut">
               <a:rPr lang="en-US" smtClean="0"/>
-              <a:t>5/15/26</a:t>
+              <a:t>5/18/26</a:t>
             </a:fld>
             <a:endParaRPr lang="en-US"/>
           </a:p>
@@ -2300,7 +2300,7 @@
           <a:p>
             <a:fld id="{5BCAD085-E8A6-8845-BD4E-CB4CCA059FC4}" type="datetimeFigureOut">
               <a:rPr lang="en-US" smtClean="0"/>
-              <a:t>5/15/26</a:t>
+              <a:t>5/18/26</a:t>
             </a:fld>
             <a:endParaRPr lang="en-US"/>
           </a:p>
@@ -2545,7 +2545,7 @@
           <a:p>
             <a:fld id="{5BCAD085-E8A6-8845-BD4E-CB4CCA059FC4}" type="datetimeFigureOut">
               <a:rPr lang="en-US" smtClean="0"/>
-              <a:t>5/15/26</a:t>
+              <a:t>5/18/26</a:t>
             </a:fld>
             <a:endParaRPr lang="en-US"/>
           </a:p>
@@ -2830,7 +2830,7 @@
           <a:p>
             <a:fld id="{5BCAD085-E8A6-8845-BD4E-CB4CCA059FC4}" type="datetimeFigureOut">
               <a:rPr lang="en-US" smtClean="0"/>
-              <a:t>5/15/26</a:t>
+              <a:t>5/18/26</a:t>
             </a:fld>
             <a:endParaRPr lang="en-US"/>
           </a:p>
@@ -3249,7 +3249,7 @@
           <a:p>
             <a:fld id="{5BCAD085-E8A6-8845-BD4E-CB4CCA059FC4}" type="datetimeFigureOut">
               <a:rPr lang="en-US" smtClean="0"/>
-              <a:t>5/15/26</a:t>
+              <a:t>5/18/26</a:t>
             </a:fld>
             <a:endParaRPr lang="en-US"/>
           </a:p>
@@ -3366,7 +3366,7 @@
           <a:p>
             <a:fld id="{5BCAD085-E8A6-8845-BD4E-CB4CCA059FC4}" type="datetimeFigureOut">
               <a:rPr lang="en-US" smtClean="0"/>
-              <a:t>5/15/26</a:t>
+              <a:t>5/18/26</a:t>
             </a:fld>
             <a:endParaRPr lang="en-US"/>
           </a:p>
@@ -3461,7 +3461,7 @@
           <a:p>
             <a:fld id="{5BCAD085-E8A6-8845-BD4E-CB4CCA059FC4}" type="datetimeFigureOut">
               <a:rPr lang="en-US" smtClean="0"/>
-              <a:t>5/15/26</a:t>
+              <a:t>5/18/26</a:t>
             </a:fld>
             <a:endParaRPr lang="en-US"/>
           </a:p>
@@ -3736,7 +3736,7 @@
           <a:p>
             <a:fld id="{5BCAD085-E8A6-8845-BD4E-CB4CCA059FC4}" type="datetimeFigureOut">
               <a:rPr lang="en-US" smtClean="0"/>
-              <a:t>5/15/26</a:t>
+              <a:t>5/18/26</a:t>
             </a:fld>
             <a:endParaRPr lang="en-US"/>
           </a:p>
@@ -3988,7 +3988,7 @@
           <a:p>
             <a:fld id="{5BCAD085-E8A6-8845-BD4E-CB4CCA059FC4}" type="datetimeFigureOut">
               <a:rPr lang="en-US" smtClean="0"/>
-              <a:t>5/15/26</a:t>
+              <a:t>5/18/26</a:t>
             </a:fld>
             <a:endParaRPr lang="en-US"/>
           </a:p>
@@ -4199,7 +4199,7 @@
           <a:p>
             <a:fld id="{5BCAD085-E8A6-8845-BD4E-CB4CCA059FC4}" type="datetimeFigureOut">
               <a:rPr lang="en-US" smtClean="0"/>
-              <a:t>5/15/26</a:t>
+              <a:t>5/18/26</a:t>
             </a:fld>
             <a:endParaRPr lang="en-US"/>
           </a:p>
@@ -18221,8 +18221,8 @@
         </p:nvSpPr>
         <p:spPr>
           <a:xfrm>
-            <a:off x="8467344" y="3730752"/>
-            <a:ext cx="3154680" cy="932688"/>
+            <a:off x="8467344" y="3383280"/>
+            <a:ext cx="3154680" cy="1280160"/>
           </a:xfrm>
           <a:prstGeom prst="rect">
             <a:avLst/>
@@ -19459,7 +19459,7 @@
           <a:lstStyle/>
           <a:p>
             <a:pPr algn="ctr"/>
-            <a:endParaRPr/>
+            <a:endParaRPr dirty="0"/>
           </a:p>
         </p:txBody>
       </p:sp>

</xml_diff>